<commit_message>
Deepen Weeks 10-15 (modern unit) into full lectures + speaker notes
Adds per-slide speaker notes to the modern-stack decks (API, memory safety, supply
chain, cloud/container, AI-LLM, DevSecOps) following the W1-6 template — delivery
script, timing, questions, misconceptions, and links to each week's game/quiz/project.
The decks were already content-rich (worked examples, 2020-2025 real cases, CWE maps).

Rebuilt week10-15.pptx (13-15 speaker-note parts each; notes don't render on slides).
QA: clean on the white theme.

All 12 teaching weeks (W1-6, 10-15) are now lecture-ready with speaker notes.

Co-Authored-By: Claude Opus 4.8 <noreply@anthropic.com>
</commit_message>
<xml_diff>
--- a/slides/pptx/week10.pptx
+++ b/slides/pptx/week10.pptx
@@ -515,7 +515,7 @@
           <a:p>
             <a:r>
               <a:rPr lang="en-US" dirty="0"/>
-              <a:t/>
+              <a:t>Welcome back after midterm. Hook: change one number in an API URL and read a stranger's car location — that's the #1 API bug, and it's everywhere. Today: the OWASP API Top 10, hands-on. ~2 min.</a:t>
             </a:r>
             <a:endParaRPr lang="en-US" dirty="0"/>
           </a:p>
@@ -603,7 +603,7 @@
           <a:p>
             <a:r>
               <a:rPr lang="en-US" dirty="0"/>
-              <a:t/>
+              <a:t>Shows that "a feature" + missing authz = RCE. A legit admin editor, abused once an attacker has access. Ties to least-privilege: even admins shouldn't be able to inject executable code. ~3 min.</a:t>
             </a:r>
             <a:endParaRPr lang="en-US" dirty="0"/>
           </a:p>
@@ -691,7 +691,7 @@
           <a:p>
             <a:r>
               <a:rPr lang="en-US" dirty="0"/>
-              <a:t/>
+              <a:t>Explain before lab. crAPI is OWASP's intentionally vulnerable API. Round 2 (fix) is graded. Note crAPI is heavier (compose stack) — start the pull early. Q6 of the quiz asks for the mass-assignment field + fix + flag. ~3 min.</a:t>
             </a:r>
             <a:endParaRPr lang="en-US" dirty="0"/>
           </a:p>
@@ -779,7 +779,7 @@
           <a:p>
             <a:r>
               <a:rPr lang="en-US" dirty="0"/>
-              <a:t/>
+              <a:t>Before/after + API-Top-10 mapping. AI-resilient tasks count. Also the NoteVault project API task.</a:t>
             </a:r>
             <a:endParaRPr lang="en-US" dirty="0"/>
           </a:p>
@@ -867,7 +867,7 @@
           <a:p>
             <a:r>
               <a:rPr lang="en-US" dirty="0"/>
-              <a:t/>
+              <a:t>Recap. Cold-call: "what one check stops BOLA?" (per-object ownership authorization). ~2 min.</a:t>
             </a:r>
             <a:endParaRPr lang="en-US" dirty="0"/>
           </a:p>
@@ -955,7 +955,7 @@
           <a:p>
             <a:r>
               <a:rPr lang="en-US" dirty="0"/>
-              <a:t/>
+              <a:t>Cliffhanger: "Next week we leave the web — crash a C binary with a fuzzer and hijack its execution, then rewrite it in Rust." Remind crAPI pulled before next session.</a:t>
             </a:r>
             <a:endParaRPr lang="en-US" dirty="0"/>
           </a:p>
@@ -1043,7 +1043,7 @@
           <a:p>
             <a:r>
               <a:rPr lang="en-US" dirty="0"/>
-              <a:t/>
+              <a:t>Roadmap, 1 min. Frame: APIs are where the web bugs (IDOR, injection) reappear without a browser to hide behind. Lab = raid the deliberately vulnerable crAPI app, then fix it.</a:t>
             </a:r>
             <a:endParaRPr lang="en-US" dirty="0"/>
           </a:p>
@@ -1131,7 +1131,7 @@
           <a:p>
             <a:r>
               <a:rPr lang="en-US" dirty="0"/>
-              <a:t/>
+              <a:t>1-min bridge from the web unit. The midterm tested W1-6; APIs reuse all of it. Ask: "what was IDOR?" — because BOLA (the #1 API risk) is literally IDOR at API scale.</a:t>
             </a:r>
             <a:endParaRPr lang="en-US" dirty="0"/>
           </a:p>
@@ -1219,7 +1219,7 @@
           <a:p>
             <a:r>
               <a:rPr lang="en-US" dirty="0"/>
-              <a:t/>
+              <a:t>Key framing. No browser = no SameSite/CSP safety net; the API is the raw attack surface. APIs expose object ids by design (REST). Mobile/SPA clients are fully attacker-controlled — never trust what they send. ~5 min.</a:t>
             </a:r>
             <a:endParaRPr lang="en-US" dirty="0"/>
           </a:p>
@@ -1307,7 +1307,7 @@
           <a:p>
             <a:r>
               <a:rPr lang="en-US" dirty="0"/>
-              <a:t/>
+              <a:t>The worked example — this is the crAPI BOLA challenge. Same root cause as W6 IDOR: authenticated, but no per-object ownership check. Ask: "the server knows who I am — why does it still leak 1002?" (it never checks the object belongs to me). ~6 min.</a:t>
             </a:r>
             <a:endParaRPr lang="en-US" dirty="0"/>
           </a:p>
@@ -1395,7 +1395,7 @@
           <a:p>
             <a:r>
               <a:rPr lang="en-US" dirty="0"/>
-              <a:t/>
+              <a:t>Walk it: the server takes the JSON and binds every field to the model, including ones the UI never exposes (role, credit, is_verified). This is the crAPI mass-assignment challenge and the weekly quiz Q6. Fix = allow-list the bindable fields. ~5 min.</a:t>
             </a:r>
             <a:endParaRPr lang="en-US" dirty="0"/>
           </a:p>
@@ -1483,7 +1483,7 @@
           <a:p>
             <a:r>
               <a:rPr lang="en-US" dirty="0"/>
-              <a:t/>
+              <a:t>Round out the list. API4 = no rate limit → brute force / cost blowup. Excessive data exposure = API returns the whole user object and the UI just hides fields — attacker reads the raw JSON. ~4 min.</a:t>
             </a:r>
             <a:endParaRPr lang="en-US" dirty="0"/>
           </a:p>
@@ -1571,7 +1571,7 @@
           <a:p>
             <a:r>
               <a:rPr lang="en-US" dirty="0"/>
-              <a:t/>
+              <a:t>The payoff. #1: ownership check on every object access (kills BOLA). DTO/allow-list binding kills mass assignment AND excessive exposure in one move. Schema validation at the edge rejects junk early. ~5 min.</a:t>
             </a:r>
             <a:endParaRPr lang="en-US" dirty="0"/>
           </a:p>
@@ -1659,7 +1659,7 @@
           <a:p>
             <a:r>
               <a:rPr lang="en-US" dirty="0"/>
-              <a:t/>
+              <a:t>Practical recon for the CTF/midterm-style tasks: enumerate before you exploit. Emphasize ethics + scope: only against provided sandbox targets. This is the "map the attack surface" muscle from W1, applied live. ~4 min.</a:t>
             </a:r>
             <a:endParaRPr lang="en-US" dirty="0"/>
           </a:p>
@@ -3352,11 +3352,11 @@
         <p:spPr>
           <a:xfrm>
             <a:off x="457200" y="1325880"/>
-            <a:ext cx="8229600" cy="1207008"/>
+            <a:ext cx="8229600" cy="1517904"/>
           </a:xfrm>
           <a:prstGeom prst="roundRect">
             <a:avLst>
-              <a:gd name="adj" fmla="val 6061"/>
+              <a:gd name="adj" fmla="val 4819"/>
             </a:avLst>
           </a:prstGeom>
           <a:solidFill>
@@ -3381,7 +3381,7 @@
         <p:spPr>
           <a:xfrm>
             <a:off x="731520" y="1435608"/>
-            <a:ext cx="7680960" cy="987552"/>
+            <a:ext cx="7680960" cy="1298448"/>
           </a:xfrm>
           <a:prstGeom prst="rect">
             <a:avLst/>
@@ -3452,6 +3452,27 @@
                 <a:cs typeface="Calibri" pitchFamily="34" charset="-120"/>
               </a:rPr>
               <a:t>Proof exploits now fail</a:t>
+            </a:r>
+            <a:endParaRPr lang="en-US" sz="1400" dirty="0"/>
+          </a:p>
+          <a:p>
+            <a:pPr marL="342900" indent="-342900">
+              <a:spcAft>
+                <a:spcPts val="600"/>
+              </a:spcAft>
+              <a:buSzPct val="100000"/>
+              <a:buChar char="•"/>
+            </a:pPr>
+            <a:r>
+              <a:rPr lang="en-US" sz="1400" dirty="0">
+                <a:solidFill>
+                  <a:srgbClr val="1F2937"/>
+                </a:solidFill>
+                <a:latin typeface="Calibri" pitchFamily="34" charset="0"/>
+                <a:ea typeface="Calibri" pitchFamily="34" charset="-122"/>
+                <a:cs typeface="Calibri" pitchFamily="34" charset="-120"/>
+              </a:rPr>
+              <a:t>+ Audit the AI / EiPE / Prompt Problem (see worksheet)</a:t>
             </a:r>
             <a:endParaRPr lang="en-US" sz="1400" dirty="0"/>
           </a:p>

</xml_diff>